<commit_message>
Investiga a causa do plato de 2018 e reescreve projecao e conclusoes
</commit_message>
<xml_diff>
--- a/relatorios/apresentacao_crescimento_receita.pptx
+++ b/relatorios/apresentacao_crescimento_receita.pptx
@@ -4,9 +4,6 @@
   <p:sldMasterIdLst>
     <p:sldMasterId id="2147483648" r:id="rId1"/>
   </p:sldMasterIdLst>
-  <p:notesMasterIdLst>
-    <p:notesMasterId r:id="rId16"/>
-  </p:notesMasterIdLst>
   <p:sldIdLst>
     <p:sldId id="256" r:id="rId2"/>
     <p:sldId id="257" r:id="rId3"/>
@@ -22,7 +19,12 @@
     <p:sldId id="267" r:id="rId13"/>
     <p:sldId id="268" r:id="rId14"/>
     <p:sldId id="269" r:id="rId15"/>
+    <p:sldId id="270" r:id="rId16"/>
+    <p:sldId id="271" r:id="rId17"/>
   </p:sldIdLst>
+  <p:notesMasterIdLst>
+    <p:notesMasterId r:id="rId18"/>
+  </p:notesMasterIdLst>
   <p:sldSz cx="12192000" cy="6858000"/>
   <p:notesSz cx="6858000" cy="12192000"/>
   <p:defaultTextStyle>
@@ -117,55 +119,7 @@
       </a:defRPr>
     </a:lvl9pPr>
   </p:defaultTextStyle>
-  <p:extLst>
-    <p:ext uri="{EFAFB233-063F-42B5-8137-9DF3F51BA10A}">
-      <p15:sldGuideLst xmlns:p15="http://schemas.microsoft.com/office/powerpoint/2012/main"/>
-    </p:ext>
-  </p:extLst>
 </p:presentation>
-</file>
-
-<file path=ppt/changesInfos/changesInfo1.xml><?xml version="1.0" encoding="utf-8"?>
-<pc:chgInfo xmlns:a="http://schemas.openxmlformats.org/drawingml/2006/main" xmlns:r="http://schemas.openxmlformats.org/officeDocument/2006/relationships" xmlns:ac="http://schemas.microsoft.com/office/drawing/2013/main/command" xmlns:pc="http://schemas.microsoft.com/office/powerpoint/2013/main/command">
-  <pc:docChgLst>
-    <pc:chgData name="Evanio Carvalho" userId="a84c28dca2c48ebb" providerId="LiveId" clId="{9951D568-64CE-4441-9351-9161622AC723}"/>
-    <pc:docChg chg="delSld modSld sldOrd">
-      <pc:chgData name="Evanio Carvalho" userId="a84c28dca2c48ebb" providerId="LiveId" clId="{9951D568-64CE-4441-9351-9161622AC723}" dt="2026-08-15T13:37:10.624" v="3" actId="2696"/>
-      <pc:docMkLst>
-        <pc:docMk/>
-      </pc:docMkLst>
-      <pc:sldChg chg="modSp mod">
-        <pc:chgData name="Evanio Carvalho" userId="a84c28dca2c48ebb" providerId="LiveId" clId="{9951D568-64CE-4441-9351-9161622AC723}" dt="2026-08-15T13:35:45.201" v="0" actId="20577"/>
-        <pc:sldMkLst>
-          <pc:docMk/>
-          <pc:sldMk cId="0" sldId="256"/>
-        </pc:sldMkLst>
-        <pc:spChg chg="mod">
-          <ac:chgData name="Evanio Carvalho" userId="a84c28dca2c48ebb" providerId="LiveId" clId="{9951D568-64CE-4441-9351-9161622AC723}" dt="2026-08-15T13:35:45.201" v="0" actId="20577"/>
-          <ac:spMkLst>
-            <pc:docMk/>
-            <pc:sldMk cId="0" sldId="256"/>
-            <ac:spMk id="6" creationId="{00000000-0000-0000-0000-000000000000}"/>
-          </ac:spMkLst>
-        </pc:spChg>
-      </pc:sldChg>
-      <pc:sldChg chg="ord">
-        <pc:chgData name="Evanio Carvalho" userId="a84c28dca2c48ebb" providerId="LiveId" clId="{9951D568-64CE-4441-9351-9161622AC723}" dt="2026-08-15T13:36:11.392" v="2"/>
-        <pc:sldMkLst>
-          <pc:docMk/>
-          <pc:sldMk cId="0" sldId="260"/>
-        </pc:sldMkLst>
-      </pc:sldChg>
-      <pc:sldChg chg="del">
-        <pc:chgData name="Evanio Carvalho" userId="a84c28dca2c48ebb" providerId="LiveId" clId="{9951D568-64CE-4441-9351-9161622AC723}" dt="2026-08-15T13:37:10.624" v="3" actId="2696"/>
-        <pc:sldMkLst>
-          <pc:docMk/>
-          <pc:sldMk cId="0" sldId="270"/>
-        </pc:sldMkLst>
-      </pc:sldChg>
-    </pc:docChg>
-  </pc:docChgLst>
-</pc:chgInfo>
 </file>
 
 <file path=ppt/notesMasters/notesMaster1.xml><?xml version="1.0" encoding="utf-8"?>
@@ -190,10 +144,234 @@
           <a:chExt cx="0" cy="0"/>
         </a:xfrm>
       </p:grpSpPr>
+      <p:sp>
+        <p:nvSpPr>
+          <p:cNvPr id="2" name="Header Placeholder 1"/>
+          <p:cNvSpPr>
+            <a:spLocks noGrp="1"/>
+          </p:cNvSpPr>
+          <p:nvPr>
+            <p:ph type="hdr" sz="quarter"/>
+          </p:nvPr>
+        </p:nvSpPr>
+        <p:spPr>
+          <a:xfrm>
+            <a:off x="0" y="0"/>
+            <a:ext cx="2971800" cy="458788"/>
+          </a:xfrm>
+          <a:prstGeom prst="rect">
+            <a:avLst/>
+          </a:prstGeom>
+        </p:spPr>
+        <p:txBody>
+          <a:bodyPr vert="horz" lIns="91440" tIns="45720" rIns="91440" bIns="45720" rtlCol="0"/>
+          <a:lstStyle>
+            <a:lvl1pPr algn="l">
+              <a:defRPr sz="1200"/>
+            </a:lvl1pPr>
+          </a:lstStyle>
+          <a:p>
+            <a:endParaRPr lang="en-US"/>
+          </a:p>
+        </p:txBody>
+      </p:sp>
+      <p:sp>
+        <p:nvSpPr>
+          <p:cNvPr id="3" name="Date Placeholder 2"/>
+          <p:cNvSpPr>
+            <a:spLocks noGrp="1"/>
+          </p:cNvSpPr>
+          <p:nvPr>
+            <p:ph type="dt" idx="1"/>
+          </p:nvPr>
+        </p:nvSpPr>
+        <p:spPr>
+          <a:xfrm>
+            <a:off x="3884613" y="0"/>
+            <a:ext cx="2971800" cy="458788"/>
+          </a:xfrm>
+          <a:prstGeom prst="rect">
+            <a:avLst/>
+          </a:prstGeom>
+        </p:spPr>
+        <p:txBody>
+          <a:bodyPr vert="horz" lIns="91440" tIns="45720" rIns="91440" bIns="45720" rtlCol="0"/>
+          <a:lstStyle>
+            <a:lvl1pPr algn="r">
+              <a:defRPr sz="1200"/>
+            </a:lvl1pPr>
+          </a:lstStyle>
+          <a:p>
+            <a:fld id="{5282F153-3F37-0F45-9E97-73ACFA13230C}" type="datetimeFigureOut">
+              <a:rPr lang="en-US"/>
+              <a:t>7/23/19</a:t>
+            </a:fld>
+            <a:endParaRPr lang="en-US"/>
+          </a:p>
+        </p:txBody>
+      </p:sp>
+      <p:sp>
+        <p:nvSpPr>
+          <p:cNvPr id="4" name="Slide Image Placeholder 3"/>
+          <p:cNvSpPr>
+            <a:spLocks noGrp="1" noRot="1" noChangeAspect="1"/>
+          </p:cNvSpPr>
+          <p:nvPr>
+            <p:ph type="sldImg" idx="2"/>
+          </p:nvPr>
+        </p:nvSpPr>
+        <p:spPr>
+          <a:xfrm>
+            <a:off x="685800" y="1143000"/>
+            <a:ext cx="5486400" cy="3086100"/>
+          </a:xfrm>
+          <a:prstGeom prst="rect">
+            <a:avLst/>
+          </a:prstGeom>
+          <a:noFill/>
+          <a:ln w="12700">
+            <a:solidFill>
+              <a:prstClr val="black"/>
+            </a:solidFill>
+          </a:ln>
+        </p:spPr>
+        <p:txBody>
+          <a:bodyPr vert="horz" lIns="91440" tIns="45720" rIns="91440" bIns="45720" rtlCol="0" anchor="ctr"/>
+          <a:lstStyle/>
+          <a:p>
+            <a:endParaRPr lang="en-US"/>
+          </a:p>
+        </p:txBody>
+      </p:sp>
+      <p:sp>
+        <p:nvSpPr>
+          <p:cNvPr id="5" name="Notes Placeholder 4"/>
+          <p:cNvSpPr>
+            <a:spLocks noGrp="1"/>
+          </p:cNvSpPr>
+          <p:nvPr>
+            <p:ph type="body" sz="quarter" idx="3"/>
+          </p:nvPr>
+        </p:nvSpPr>
+        <p:spPr>
+          <a:xfrm>
+            <a:off x="685800" y="4400550"/>
+            <a:ext cx="5486400" cy="3600450"/>
+          </a:xfrm>
+          <a:prstGeom prst="rect">
+            <a:avLst/>
+          </a:prstGeom>
+        </p:spPr>
+        <p:txBody>
+          <a:bodyPr vert="horz" lIns="91440" tIns="45720" rIns="91440" bIns="45720" rtlCol="0"/>
+          <a:lstStyle/>
+          <a:p>
+            <a:pPr lvl="0"/>
+            <a:r>
+              <a:rPr lang="en-US"/>
+              <a:t>Click to edit Master text styles</a:t>
+            </a:r>
+          </a:p>
+          <a:p>
+            <a:pPr lvl="1"/>
+            <a:r>
+              <a:rPr lang="en-US"/>
+              <a:t>Second level</a:t>
+            </a:r>
+          </a:p>
+          <a:p>
+            <a:pPr lvl="2"/>
+            <a:r>
+              <a:rPr lang="en-US"/>
+              <a:t>Third level</a:t>
+            </a:r>
+          </a:p>
+          <a:p>
+            <a:pPr lvl="3"/>
+            <a:r>
+              <a:rPr lang="en-US"/>
+              <a:t>Fourth level</a:t>
+            </a:r>
+          </a:p>
+          <a:p>
+            <a:pPr lvl="4"/>
+            <a:r>
+              <a:rPr lang="en-US"/>
+              <a:t>Fifth level</a:t>
+            </a:r>
+          </a:p>
+        </p:txBody>
+      </p:sp>
+      <p:sp>
+        <p:nvSpPr>
+          <p:cNvPr id="6" name="Footer Placeholder 5"/>
+          <p:cNvSpPr>
+            <a:spLocks noGrp="1"/>
+          </p:cNvSpPr>
+          <p:nvPr>
+            <p:ph type="ftr" sz="quarter" idx="4"/>
+          </p:nvPr>
+        </p:nvSpPr>
+        <p:spPr>
+          <a:xfrm>
+            <a:off x="0" y="8685213"/>
+            <a:ext cx="2971800" cy="458787"/>
+          </a:xfrm>
+          <a:prstGeom prst="rect">
+            <a:avLst/>
+          </a:prstGeom>
+        </p:spPr>
+        <p:txBody>
+          <a:bodyPr vert="horz" lIns="91440" tIns="45720" rIns="91440" bIns="45720" rtlCol="0" anchor="b"/>
+          <a:lstStyle>
+            <a:lvl1pPr algn="l">
+              <a:defRPr sz="1200"/>
+            </a:lvl1pPr>
+          </a:lstStyle>
+          <a:p>
+            <a:endParaRPr lang="en-US"/>
+          </a:p>
+        </p:txBody>
+      </p:sp>
+      <p:sp>
+        <p:nvSpPr>
+          <p:cNvPr id="7" name="Slide Number Placeholder 6"/>
+          <p:cNvSpPr>
+            <a:spLocks noGrp="1"/>
+          </p:cNvSpPr>
+          <p:nvPr>
+            <p:ph type="sldNum" sz="quarter" idx="5"/>
+          </p:nvPr>
+        </p:nvSpPr>
+        <p:spPr>
+          <a:xfrm>
+            <a:off x="3884613" y="8685213"/>
+            <a:ext cx="2971800" cy="458787"/>
+          </a:xfrm>
+          <a:prstGeom prst="rect">
+            <a:avLst/>
+          </a:prstGeom>
+        </p:spPr>
+        <p:txBody>
+          <a:bodyPr vert="horz" lIns="91440" tIns="45720" rIns="91440" bIns="45720" rtlCol="0" anchor="b"/>
+          <a:lstStyle>
+            <a:lvl1pPr algn="r">
+              <a:defRPr sz="1200"/>
+            </a:lvl1pPr>
+          </a:lstStyle>
+          <a:p>
+            <a:fld id="{CE5E9CC1-C706-0F49-92D6-E571CC5EEA8F}" type="slidenum">
+              <a:rPr lang="en-US"/>
+              <a:t>‹#›</a:t>
+            </a:fld>
+            <a:endParaRPr lang="en-US"/>
+          </a:p>
+        </p:txBody>
+      </p:sp>
     </p:spTree>
     <p:extLst>
       <p:ext uri="{BB962C8B-B14F-4D97-AF65-F5344CB8AC3E}">
-        <p14:creationId xmlns:p14="http://schemas.microsoft.com/office/powerpoint/2010/main" val="617825271"/>
+        <p14:creationId xmlns:p14="http://schemas.microsoft.com/office/powerpoint/2010/main" val="1024086991"/>
       </p:ext>
     </p:extLst>
   </p:cSld>
@@ -337,6 +515,10 @@
           <a:bodyPr/>
           <a:lstStyle/>
           <a:p>
+            <a:r>
+              <a:rPr lang="en-US" dirty="0"/>
+              <a:t/>
+            </a:r>
             <a:endParaRPr lang="en-US" dirty="0"/>
           </a:p>
         </p:txBody>
@@ -421,6 +603,10 @@
           <a:bodyPr/>
           <a:lstStyle/>
           <a:p>
+            <a:r>
+              <a:rPr lang="en-US" dirty="0"/>
+              <a:t/>
+            </a:r>
             <a:endParaRPr lang="en-US" dirty="0"/>
           </a:p>
         </p:txBody>
@@ -505,6 +691,10 @@
           <a:bodyPr/>
           <a:lstStyle/>
           <a:p>
+            <a:r>
+              <a:rPr lang="en-US" dirty="0"/>
+              <a:t/>
+            </a:r>
             <a:endParaRPr lang="en-US" dirty="0"/>
           </a:p>
         </p:txBody>
@@ -589,6 +779,10 @@
           <a:bodyPr/>
           <a:lstStyle/>
           <a:p>
+            <a:r>
+              <a:rPr lang="en-US" dirty="0"/>
+              <a:t/>
+            </a:r>
             <a:endParaRPr lang="en-US" dirty="0"/>
           </a:p>
         </p:txBody>
@@ -673,6 +867,10 @@
           <a:bodyPr/>
           <a:lstStyle/>
           <a:p>
+            <a:r>
+              <a:rPr lang="en-US" dirty="0"/>
+              <a:t/>
+            </a:r>
             <a:endParaRPr lang="en-US" dirty="0"/>
           </a:p>
         </p:txBody>
@@ -757,6 +955,10 @@
           <a:bodyPr/>
           <a:lstStyle/>
           <a:p>
+            <a:r>
+              <a:rPr lang="en-US" dirty="0"/>
+              <a:t/>
+            </a:r>
             <a:endParaRPr lang="en-US" dirty="0"/>
           </a:p>
         </p:txBody>
@@ -779,6 +981,182 @@
             <a:fld id="{F7021451-1387-4CA6-816F-3879F97B5CBC}" type="slidenum">
               <a:rPr lang="en-US"/>
               <a:t>14</a:t>
+            </a:fld>
+            <a:endParaRPr lang="en-US"/>
+          </a:p>
+        </p:txBody>
+      </p:sp>
+    </p:spTree>
+    <p:extLst>
+      <p:ext uri="{BB962C8B-B14F-4D97-AF65-F5344CB8AC3E}">
+        <p14:creationId xmlns:p14="http://schemas.microsoft.com/office/powerpoint/2010/main" val="1024086991"/>
+      </p:ext>
+    </p:extLst>
+  </p:cSld>
+  <p:clrMapOvr>
+    <a:masterClrMapping/>
+  </p:clrMapOvr>
+</p:notes>
+</file>
+
+<file path=ppt/notesSlides/notesSlide15.xml><?xml version="1.0" encoding="utf-8"?>
+<p:notes xmlns:a="http://schemas.openxmlformats.org/drawingml/2006/main" xmlns:r="http://schemas.openxmlformats.org/officeDocument/2006/relationships" xmlns:p="http://schemas.openxmlformats.org/presentationml/2006/main">
+  <p:cSld>
+    <p:spTree>
+      <p:nvGrpSpPr>
+        <p:cNvPr id="1" name=""/>
+        <p:cNvGrpSpPr/>
+        <p:nvPr/>
+      </p:nvGrpSpPr>
+      <p:grpSpPr>
+        <a:xfrm>
+          <a:off x="0" y="0"/>
+          <a:ext cx="0" cy="0"/>
+          <a:chOff x="0" y="0"/>
+          <a:chExt cx="0" cy="0"/>
+        </a:xfrm>
+      </p:grpSpPr>
+      <p:sp>
+        <p:nvSpPr>
+          <p:cNvPr id="2" name="Slide Image Placeholder 1"/>
+          <p:cNvSpPr>
+            <a:spLocks noGrp="1" noRot="1" noChangeAspect="1"/>
+          </p:cNvSpPr>
+          <p:nvPr>
+            <p:ph type="sldImg"/>
+          </p:nvPr>
+        </p:nvSpPr>
+        <p:spPr/>
+      </p:sp>
+      <p:sp>
+        <p:nvSpPr>
+          <p:cNvPr id="3" name="Notes Placeholder 2"/>
+          <p:cNvSpPr>
+            <a:spLocks noGrp="1"/>
+          </p:cNvSpPr>
+          <p:nvPr>
+            <p:ph type="body" idx="1"/>
+          </p:nvPr>
+        </p:nvSpPr>
+        <p:spPr/>
+        <p:txBody>
+          <a:bodyPr/>
+          <a:lstStyle/>
+          <a:p>
+            <a:r>
+              <a:rPr lang="en-US" dirty="0"/>
+              <a:t/>
+            </a:r>
+            <a:endParaRPr lang="en-US" dirty="0"/>
+          </a:p>
+        </p:txBody>
+      </p:sp>
+      <p:sp>
+        <p:nvSpPr>
+          <p:cNvPr id="4" name="Slide Number Placeholder 3"/>
+          <p:cNvSpPr>
+            <a:spLocks noGrp="1"/>
+          </p:cNvSpPr>
+          <p:nvPr>
+            <p:ph type="sldNum" sz="quarter" idx="10"/>
+          </p:nvPr>
+        </p:nvSpPr>
+        <p:spPr/>
+        <p:txBody>
+          <a:bodyPr/>
+          <a:lstStyle/>
+          <a:p>
+            <a:fld id="{F7021451-1387-4CA6-816F-3879F97B5CBC}" type="slidenum">
+              <a:rPr lang="en-US"/>
+              <a:t>15</a:t>
+            </a:fld>
+            <a:endParaRPr lang="en-US"/>
+          </a:p>
+        </p:txBody>
+      </p:sp>
+    </p:spTree>
+    <p:extLst>
+      <p:ext uri="{BB962C8B-B14F-4D97-AF65-F5344CB8AC3E}">
+        <p14:creationId xmlns:p14="http://schemas.microsoft.com/office/powerpoint/2010/main" val="1024086991"/>
+      </p:ext>
+    </p:extLst>
+  </p:cSld>
+  <p:clrMapOvr>
+    <a:masterClrMapping/>
+  </p:clrMapOvr>
+</p:notes>
+</file>
+
+<file path=ppt/notesSlides/notesSlide16.xml><?xml version="1.0" encoding="utf-8"?>
+<p:notes xmlns:a="http://schemas.openxmlformats.org/drawingml/2006/main" xmlns:r="http://schemas.openxmlformats.org/officeDocument/2006/relationships" xmlns:p="http://schemas.openxmlformats.org/presentationml/2006/main">
+  <p:cSld>
+    <p:spTree>
+      <p:nvGrpSpPr>
+        <p:cNvPr id="1" name=""/>
+        <p:cNvGrpSpPr/>
+        <p:nvPr/>
+      </p:nvGrpSpPr>
+      <p:grpSpPr>
+        <a:xfrm>
+          <a:off x="0" y="0"/>
+          <a:ext cx="0" cy="0"/>
+          <a:chOff x="0" y="0"/>
+          <a:chExt cx="0" cy="0"/>
+        </a:xfrm>
+      </p:grpSpPr>
+      <p:sp>
+        <p:nvSpPr>
+          <p:cNvPr id="2" name="Slide Image Placeholder 1"/>
+          <p:cNvSpPr>
+            <a:spLocks noGrp="1" noRot="1" noChangeAspect="1"/>
+          </p:cNvSpPr>
+          <p:nvPr>
+            <p:ph type="sldImg"/>
+          </p:nvPr>
+        </p:nvSpPr>
+        <p:spPr/>
+      </p:sp>
+      <p:sp>
+        <p:nvSpPr>
+          <p:cNvPr id="3" name="Notes Placeholder 2"/>
+          <p:cNvSpPr>
+            <a:spLocks noGrp="1"/>
+          </p:cNvSpPr>
+          <p:nvPr>
+            <p:ph type="body" idx="1"/>
+          </p:nvPr>
+        </p:nvSpPr>
+        <p:spPr/>
+        <p:txBody>
+          <a:bodyPr/>
+          <a:lstStyle/>
+          <a:p>
+            <a:r>
+              <a:rPr lang="en-US" dirty="0"/>
+              <a:t/>
+            </a:r>
+            <a:endParaRPr lang="en-US" dirty="0"/>
+          </a:p>
+        </p:txBody>
+      </p:sp>
+      <p:sp>
+        <p:nvSpPr>
+          <p:cNvPr id="4" name="Slide Number Placeholder 3"/>
+          <p:cNvSpPr>
+            <a:spLocks noGrp="1"/>
+          </p:cNvSpPr>
+          <p:nvPr>
+            <p:ph type="sldNum" sz="quarter" idx="10"/>
+          </p:nvPr>
+        </p:nvSpPr>
+        <p:spPr/>
+        <p:txBody>
+          <a:bodyPr/>
+          <a:lstStyle/>
+          <a:p>
+            <a:fld id="{F7021451-1387-4CA6-816F-3879F97B5CBC}" type="slidenum">
+              <a:rPr lang="en-US"/>
+              <a:t>16</a:t>
             </a:fld>
             <a:endParaRPr lang="en-US"/>
           </a:p>
@@ -841,6 +1219,10 @@
           <a:bodyPr/>
           <a:lstStyle/>
           <a:p>
+            <a:r>
+              <a:rPr lang="en-US" dirty="0"/>
+              <a:t/>
+            </a:r>
             <a:endParaRPr lang="en-US" dirty="0"/>
           </a:p>
         </p:txBody>
@@ -925,6 +1307,10 @@
           <a:bodyPr/>
           <a:lstStyle/>
           <a:p>
+            <a:r>
+              <a:rPr lang="en-US" dirty="0"/>
+              <a:t/>
+            </a:r>
             <a:endParaRPr lang="en-US" dirty="0"/>
           </a:p>
         </p:txBody>
@@ -1009,6 +1395,10 @@
           <a:bodyPr/>
           <a:lstStyle/>
           <a:p>
+            <a:r>
+              <a:rPr lang="en-US" dirty="0"/>
+              <a:t/>
+            </a:r>
             <a:endParaRPr lang="en-US" dirty="0"/>
           </a:p>
         </p:txBody>
@@ -1093,6 +1483,10 @@
           <a:bodyPr/>
           <a:lstStyle/>
           <a:p>
+            <a:r>
+              <a:rPr lang="en-US" dirty="0"/>
+              <a:t/>
+            </a:r>
             <a:endParaRPr lang="en-US" dirty="0"/>
           </a:p>
         </p:txBody>
@@ -1177,6 +1571,10 @@
           <a:bodyPr/>
           <a:lstStyle/>
           <a:p>
+            <a:r>
+              <a:rPr lang="en-US" dirty="0"/>
+              <a:t/>
+            </a:r>
             <a:endParaRPr lang="en-US" dirty="0"/>
           </a:p>
         </p:txBody>
@@ -1261,6 +1659,10 @@
           <a:bodyPr/>
           <a:lstStyle/>
           <a:p>
+            <a:r>
+              <a:rPr lang="en-US" dirty="0"/>
+              <a:t/>
+            </a:r>
             <a:endParaRPr lang="en-US" dirty="0"/>
           </a:p>
         </p:txBody>
@@ -1345,6 +1747,10 @@
           <a:bodyPr/>
           <a:lstStyle/>
           <a:p>
+            <a:r>
+              <a:rPr lang="en-US" dirty="0"/>
+              <a:t/>
+            </a:r>
             <a:endParaRPr lang="en-US" dirty="0"/>
           </a:p>
         </p:txBody>
@@ -1429,6 +1835,10 @@
           <a:bodyPr/>
           <a:lstStyle/>
           <a:p>
+            <a:r>
+              <a:rPr lang="en-US" dirty="0"/>
+              <a:t/>
+            </a:r>
             <a:endParaRPr lang="en-US" dirty="0"/>
           </a:p>
         </p:txBody>
@@ -1502,11 +1912,6 @@
 <file path=ppt/slideMasters/slideMaster1.xml><?xml version="1.0" encoding="utf-8"?>
 <p:sldMaster xmlns:a="http://schemas.openxmlformats.org/drawingml/2006/main" xmlns:r="http://schemas.openxmlformats.org/officeDocument/2006/relationships" xmlns:p="http://schemas.openxmlformats.org/presentationml/2006/main">
   <p:cSld>
-    <p:bg>
-      <p:bgRef idx="1001">
-        <a:schemeClr val="bg1"/>
-      </p:bgRef>
-    </p:bg>
     <p:spTree>
       <p:nvGrpSpPr>
         <p:cNvPr id="1" name=""/>
@@ -1819,7 +2224,7 @@
           <a:bodyPr wrap="square" rtlCol="0" anchor="ctr"/>
           <a:lstStyle/>
           <a:p>
-            <a:pPr marL="0" indent="0">
+            <a:pPr indent="0" marL="0">
               <a:buNone/>
             </a:pPr>
             <a:r>
@@ -1858,7 +2263,7 @@
           <a:bodyPr wrap="square" rtlCol="0" anchor="ctr"/>
           <a:lstStyle/>
           <a:p>
-            <a:pPr marL="0" indent="0">
+            <a:pPr indent="0" marL="0">
               <a:buNone/>
             </a:pPr>
             <a:r>
@@ -1920,7 +2325,7 @@
           <a:bodyPr wrap="square" rtlCol="0" anchor="ctr"/>
           <a:lstStyle/>
           <a:p>
-            <a:pPr marL="0" indent="0">
+            <a:pPr indent="0" marL="0">
               <a:buNone/>
             </a:pPr>
             <a:r>
@@ -1959,7 +2364,7 @@
           <a:bodyPr wrap="square" rtlCol="0" anchor="ctr"/>
           <a:lstStyle/>
           <a:p>
-            <a:pPr marL="0" indent="0">
+            <a:pPr indent="0" marL="0">
               <a:buNone/>
             </a:pPr>
             <a:r>
@@ -1971,7 +2376,7 @@
                 <a:ea typeface="Calibri" pitchFamily="34" charset="-122"/>
                 <a:cs typeface="Calibri" pitchFamily="34" charset="-120"/>
               </a:rPr>
-              <a:t>Evanio Carvalho</a:t>
+              <a:t>Evanio Alves Carvalho</a:t>
             </a:r>
             <a:endParaRPr lang="en-US" sz="1600" dirty="0"/>
           </a:p>
@@ -2023,7 +2428,7 @@
           <a:bodyPr wrap="square" rtlCol="0" anchor="ctr"/>
           <a:lstStyle/>
           <a:p>
-            <a:pPr marL="0" indent="0">
+            <a:pPr indent="0" marL="0">
               <a:buNone/>
             </a:pPr>
             <a:r>
@@ -2043,15 +2448,15 @@
       </p:sp>
       <p:pic>
         <p:nvPicPr>
-          <p:cNvPr id="3" name="Image 0" descr="/sessions/nice-great-mayer/mnt/outputs/pptx_project/assets_simples/chart_04_top_estados.png"/>
+          <p:cNvPr id="3" name="Image 0" descr="/sessions/nice-great-mayer/mnt/outputs/pptx_project/assets_simples/chart_04_top_estados.png">    </p:cNvPr>
           <p:cNvPicPr>
             <a:picLocks noChangeAspect="1"/>
           </p:cNvPicPr>
           <p:nvPr/>
         </p:nvPicPr>
         <p:blipFill>
-          <a:blip r:embed="rId3"/>
-          <a:srcRect/>
+          <a:blip r:embed="rId1"/>
+          <a:srcRect l="0" r="0" t="0" b="0"/>
           <a:stretch/>
         </p:blipFill>
         <p:spPr>
@@ -2170,7 +2575,7 @@
           <a:bodyPr wrap="square" rtlCol="0" anchor="ctr"/>
           <a:lstStyle/>
           <a:p>
-            <a:pPr marL="0" indent="0">
+            <a:pPr indent="0" marL="0">
               <a:buNone/>
             </a:pPr>
             <a:r>
@@ -2234,7 +2639,7 @@
           <a:bodyPr wrap="square" rtlCol="0" anchor="ctr"/>
           <a:lstStyle/>
           <a:p>
-            <a:pPr marL="0" indent="0">
+            <a:pPr indent="0" marL="0">
               <a:buNone/>
             </a:pPr>
             <a:r>
@@ -2254,15 +2659,15 @@
       </p:sp>
       <p:pic>
         <p:nvPicPr>
-          <p:cNvPr id="3" name="Image 0" descr="/sessions/nice-great-mayer/mnt/outputs/pptx_project/assets_simples/chart_06_top_sellers.png"/>
+          <p:cNvPr id="3" name="Image 0" descr="/sessions/nice-great-mayer/mnt/outputs/pptx_project/assets_simples/chart_06_top_sellers.png">    </p:cNvPr>
           <p:cNvPicPr>
             <a:picLocks noChangeAspect="1"/>
           </p:cNvPicPr>
           <p:nvPr/>
         </p:nvPicPr>
         <p:blipFill>
-          <a:blip r:embed="rId3"/>
-          <a:srcRect/>
+          <a:blip r:embed="rId1"/>
+          <a:srcRect l="0" r="0" t="0" b="0"/>
           <a:stretch/>
         </p:blipFill>
         <p:spPr>
@@ -2381,7 +2786,7 @@
           <a:bodyPr wrap="square" rtlCol="0" anchor="ctr"/>
           <a:lstStyle/>
           <a:p>
-            <a:pPr marL="0" indent="0">
+            <a:pPr indent="0" marL="0">
               <a:buNone/>
             </a:pPr>
             <a:r>
@@ -2445,7 +2850,7 @@
           <a:bodyPr wrap="square" rtlCol="0" anchor="ctr"/>
           <a:lstStyle/>
           <a:p>
-            <a:pPr marL="0" indent="0">
+            <a:pPr indent="0" marL="0">
               <a:buNone/>
             </a:pPr>
             <a:r>
@@ -2457,7 +2862,7 @@
                 <a:ea typeface="Calibri" pitchFamily="34" charset="-122"/>
                 <a:cs typeface="Calibri" pitchFamily="34" charset="-120"/>
               </a:rPr>
-              <a:t>Projeção para os próximos meses</a:t>
+              <a:t>Por que a receita parou de crescer</a:t>
             </a:r>
             <a:endParaRPr lang="en-US" sz="2800" dirty="0"/>
           </a:p>
@@ -2465,15 +2870,15 @@
       </p:sp>
       <p:pic>
         <p:nvPicPr>
-          <p:cNvPr id="3" name="Image 0" descr="/sessions/nice-great-mayer/mnt/outputs/pptx_project/assets_simples/chart_08_previsao.png"/>
+          <p:cNvPr id="3" name="Image 0" descr="/sessions/nice-great-mayer/mnt/outputs/pptx_project/assets_simples/chart_09_vendedores_clientes.png">    </p:cNvPr>
           <p:cNvPicPr>
             <a:picLocks noChangeAspect="1"/>
           </p:cNvPicPr>
           <p:nvPr/>
         </p:nvPicPr>
         <p:blipFill>
-          <a:blip r:embed="rId3"/>
-          <a:srcRect/>
+          <a:blip r:embed="rId1"/>
+          <a:srcRect l="0" r="0" t="0" b="0"/>
           <a:stretch/>
         </p:blipFill>
         <p:spPr>
@@ -2523,7 +2928,7 @@
                 <a:ea typeface="Calibri" pitchFamily="34" charset="-122"/>
                 <a:cs typeface="Calibri" pitchFamily="34" charset="-120"/>
               </a:rPr>
-              <a:t>Como a receita está estável, usei a média dos últimos 3 meses para estimar os próximos.</a:t>
+              <a:t>Em 2018 os vendedores ativos subiram de 968 para 1.266, um crescimento de 31%.</a:t>
             </a:r>
             <a:endParaRPr lang="en-US" sz="1500" dirty="0"/>
           </a:p>
@@ -2544,7 +2949,7 @@
                 <a:ea typeface="Calibri" pitchFamily="34" charset="-122"/>
                 <a:cs typeface="Calibri" pitchFamily="34" charset="-120"/>
               </a:rPr>
-              <a:t>Isso dá cerca de R$ 1 milhão por mês, ou R$ 3 milhões no trimestre.</a:t>
+              <a:t>Os clientes fizeram o contrário: caíram de 7.088 para 6.380, uma queda de 10%.</a:t>
             </a:r>
             <a:endParaRPr lang="en-US" sz="1500" dirty="0"/>
           </a:p>
@@ -2565,7 +2970,28 @@
                 <a:ea typeface="Calibri" pitchFamily="34" charset="-122"/>
                 <a:cs typeface="Calibri" pitchFamily="34" charset="-120"/>
               </a:rPr>
-              <a:t>É 15% acima do mesmo trimestre de 2017. Novembro deve ficar acima disso por causa da Black Friday.</a:t>
+              <a:t>Com isso a receita por vendedor caiu 31%, de R$ 1.138 para R$ 788.</a:t>
+            </a:r>
+            <a:endParaRPr lang="en-US" sz="1500" dirty="0"/>
+          </a:p>
+          <a:p>
+            <a:pPr marL="342900" indent="-342900">
+              <a:lnSpc>
+                <a:spcPct val="130000"/>
+              </a:lnSpc>
+              <a:buSzPct val="100000"/>
+              <a:buChar char="•"/>
+            </a:pPr>
+            <a:r>
+              <a:rPr lang="en-US" sz="1500" dirty="0">
+                <a:solidFill>
+                  <a:srgbClr val="404040"/>
+                </a:solidFill>
+                <a:latin typeface="Calibri" pitchFamily="34" charset="0"/>
+                <a:ea typeface="Calibri" pitchFamily="34" charset="-122"/>
+                <a:cs typeface="Calibri" pitchFamily="34" charset="-120"/>
+              </a:rPr>
+              <a:t>O gargalo não é falta de quem venda, é falta de quem compre.</a:t>
             </a:r>
             <a:endParaRPr lang="en-US" sz="1500" dirty="0"/>
           </a:p>
@@ -2592,7 +3018,7 @@
           <a:bodyPr wrap="square" rtlCol="0" anchor="ctr"/>
           <a:lstStyle/>
           <a:p>
-            <a:pPr marL="0" indent="0">
+            <a:pPr indent="0" marL="0">
               <a:buNone/>
             </a:pPr>
             <a:r>
@@ -2604,7 +3030,7 @@
                 <a:ea typeface="Calibri" pitchFamily="34" charset="-122"/>
                 <a:cs typeface="Calibri" pitchFamily="34" charset="-120"/>
               </a:rPr>
-              <a:t>Projeção baseada na média dos últimos 3 meses. A base termina em agosto de 2018.</a:t>
+              <a:t>Fonte: base pública Olist, clientes e vendedores distintos por mês.</a:t>
             </a:r>
             <a:endParaRPr lang="en-US" sz="1100" dirty="0"/>
           </a:p>
@@ -2643,7 +3069,7 @@
         </p:nvSpPr>
         <p:spPr>
           <a:xfrm>
-            <a:off x="731520" y="548640"/>
+            <a:off x="731520" y="457200"/>
             <a:ext cx="10698480" cy="640080"/>
           </a:xfrm>
           <a:prstGeom prst="rect">
@@ -2656,11 +3082,11 @@
           <a:bodyPr wrap="square" rtlCol="0" anchor="ctr"/>
           <a:lstStyle/>
           <a:p>
-            <a:pPr marL="0" indent="0">
+            <a:pPr indent="0" marL="0">
               <a:buNone/>
             </a:pPr>
             <a:r>
-              <a:rPr lang="en-US" sz="3000" b="1" dirty="0">
+              <a:rPr lang="en-US" sz="2800" b="1" dirty="0">
                 <a:solidFill>
                   <a:srgbClr val="1F4E79"/>
                 </a:solidFill>
@@ -2668,22 +3094,45 @@
                 <a:ea typeface="Calibri" pitchFamily="34" charset="-122"/>
                 <a:cs typeface="Calibri" pitchFamily="34" charset="-120"/>
               </a:rPr>
-              <a:t>Recomendações</a:t>
-            </a:r>
-            <a:endParaRPr lang="en-US" sz="3000" dirty="0"/>
-          </a:p>
-        </p:txBody>
-      </p:sp>
-      <p:sp>
-        <p:nvSpPr>
-          <p:cNvPr id="3" name="Text 1"/>
+              <a:t>Projeção para os próximos meses</a:t>
+            </a:r>
+            <a:endParaRPr lang="en-US" sz="2800" dirty="0"/>
+          </a:p>
+        </p:txBody>
+      </p:sp>
+      <p:pic>
+        <p:nvPicPr>
+          <p:cNvPr id="3" name="Image 0" descr="/sessions/nice-great-mayer/mnt/outputs/pptx_project/assets_simples/chart_08_previsao.png">    </p:cNvPr>
+          <p:cNvPicPr>
+            <a:picLocks noChangeAspect="1"/>
+          </p:cNvPicPr>
+          <p:nvPr/>
+        </p:nvPicPr>
+        <p:blipFill>
+          <a:blip r:embed="rId1"/>
+          <a:srcRect l="0" r="0" t="0" b="0"/>
+          <a:stretch/>
+        </p:blipFill>
+        <p:spPr>
+          <a:xfrm>
+            <a:off x="822960" y="1280160"/>
+            <a:ext cx="6949440" cy="4206240"/>
+          </a:xfrm>
+          <a:prstGeom prst="rect">
+            <a:avLst/>
+          </a:prstGeom>
+        </p:spPr>
+      </p:pic>
+      <p:sp>
+        <p:nvSpPr>
+          <p:cNvPr id="4" name="Text 1"/>
           <p:cNvSpPr/>
           <p:nvPr/>
         </p:nvSpPr>
         <p:spPr>
           <a:xfrm>
-            <a:off x="914400" y="1554480"/>
-            <a:ext cx="10332720" cy="4389120"/>
+            <a:off x="8046720" y="1463040"/>
+            <a:ext cx="3566160" cy="3840480"/>
           </a:xfrm>
           <a:prstGeom prst="rect">
             <a:avLst/>
@@ -2697,13 +3146,13 @@
           <a:p>
             <a:pPr marL="342900" indent="-342900">
               <a:lnSpc>
-                <a:spcPct val="140000"/>
+                <a:spcPct val="130000"/>
               </a:lnSpc>
               <a:buSzPct val="100000"/>
               <a:buChar char="•"/>
             </a:pPr>
             <a:r>
-              <a:rPr lang="en-US" sz="2000" dirty="0">
+              <a:rPr lang="en-US" sz="1500" dirty="0">
                 <a:solidFill>
                   <a:srgbClr val="404040"/>
                 </a:solidFill>
@@ -2711,20 +3160,20 @@
                 <a:ea typeface="Calibri" pitchFamily="34" charset="-122"/>
                 <a:cs typeface="Calibri" pitchFamily="34" charset="-120"/>
               </a:rPr>
-              <a:t>Entender por que a receita parou de crescer em 2018, antes de qualquer investimento maior</a:t>
-            </a:r>
-            <a:endParaRPr lang="en-US" sz="2000" dirty="0"/>
+              <a:t>Como a receita está estável, usei a média dos últimos 3 meses para estimar os próximos.</a:t>
+            </a:r>
+            <a:endParaRPr lang="en-US" sz="1500" dirty="0"/>
           </a:p>
           <a:p>
             <a:pPr marL="342900" indent="-342900">
               <a:lnSpc>
-                <a:spcPct val="140000"/>
+                <a:spcPct val="130000"/>
               </a:lnSpc>
               <a:buSzPct val="100000"/>
               <a:buChar char="•"/>
             </a:pPr>
             <a:r>
-              <a:rPr lang="en-US" sz="2000" dirty="0">
+              <a:rPr lang="en-US" sz="1500" dirty="0">
                 <a:solidFill>
                   <a:srgbClr val="404040"/>
                 </a:solidFill>
@@ -2732,20 +3181,20 @@
                 <a:ea typeface="Calibri" pitchFamily="34" charset="-122"/>
                 <a:cs typeface="Calibri" pitchFamily="34" charset="-120"/>
               </a:rPr>
-              <a:t>Crescer fora dos cinco maiores estados, que hoje concentram 73% da receita</a:t>
-            </a:r>
-            <a:endParaRPr lang="en-US" sz="2000" dirty="0"/>
+              <a:t>Isso dá cerca de R$ 1 milhão por mês, ou R$ 3 milhões no trimestre.</a:t>
+            </a:r>
+            <a:endParaRPr lang="en-US" sz="1500" dirty="0"/>
           </a:p>
           <a:p>
             <a:pPr marL="342900" indent="-342900">
               <a:lnSpc>
-                <a:spcPct val="140000"/>
+                <a:spcPct val="130000"/>
               </a:lnSpc>
               <a:buSzPct val="100000"/>
               <a:buChar char="•"/>
             </a:pPr>
             <a:r>
-              <a:rPr lang="en-US" sz="2000" dirty="0">
+              <a:rPr lang="en-US" sz="1500" dirty="0">
                 <a:solidFill>
                   <a:srgbClr val="404040"/>
                 </a:solidFill>
@@ -2753,20 +3202,20 @@
                 <a:ea typeface="Calibri" pitchFamily="34" charset="-122"/>
                 <a:cs typeface="Calibri" pitchFamily="34" charset="-120"/>
               </a:rPr>
-              <a:t>Trabalhar o valor do pedido, já que o crescimento veio de volume e não de ticket maior</a:t>
-            </a:r>
-            <a:endParaRPr lang="en-US" sz="2000" dirty="0"/>
+              <a:t>O número importa menos que o recado: a melhor estimativa possível é repetir os últimos meses.</a:t>
+            </a:r>
+            <a:endParaRPr lang="en-US" sz="1500" dirty="0"/>
           </a:p>
           <a:p>
             <a:pPr marL="342900" indent="-342900">
               <a:lnSpc>
-                <a:spcPct val="140000"/>
+                <a:spcPct val="130000"/>
               </a:lnSpc>
               <a:buSzPct val="100000"/>
               <a:buChar char="•"/>
             </a:pPr>
             <a:r>
-              <a:rPr lang="en-US" sz="2000" dirty="0">
+              <a:rPr lang="en-US" sz="1500" dirty="0">
                 <a:solidFill>
                   <a:srgbClr val="404040"/>
                 </a:solidFill>
@@ -2774,9 +3223,48 @@
                 <a:ea typeface="Calibri" pitchFamily="34" charset="-122"/>
                 <a:cs typeface="Calibri" pitchFamily="34" charset="-120"/>
               </a:rPr>
-              <a:t>Dar mais apoio aos vendedores que já vendem bem, sem aumentar a dependência de poucos</a:t>
-            </a:r>
-            <a:endParaRPr lang="en-US" sz="2000" dirty="0"/>
+              <a:t>Ou seja, a projeção confirma o platô. Serve como referência, não como meta.</a:t>
+            </a:r>
+            <a:endParaRPr lang="en-US" sz="1500" dirty="0"/>
+          </a:p>
+        </p:txBody>
+      </p:sp>
+      <p:sp>
+        <p:nvSpPr>
+          <p:cNvPr id="5" name="Text 2"/>
+          <p:cNvSpPr/>
+          <p:nvPr/>
+        </p:nvSpPr>
+        <p:spPr>
+          <a:xfrm>
+            <a:off x="731520" y="6035040"/>
+            <a:ext cx="10698480" cy="274320"/>
+          </a:xfrm>
+          <a:prstGeom prst="rect">
+            <a:avLst/>
+          </a:prstGeom>
+          <a:noFill/>
+          <a:ln/>
+        </p:spPr>
+        <p:txBody>
+          <a:bodyPr wrap="square" rtlCol="0" anchor="ctr"/>
+          <a:lstStyle/>
+          <a:p>
+            <a:pPr indent="0" marL="0">
+              <a:buNone/>
+            </a:pPr>
+            <a:r>
+              <a:rPr lang="en-US" sz="1100" i="1" dirty="0">
+                <a:solidFill>
+                  <a:srgbClr val="808080"/>
+                </a:solidFill>
+                <a:latin typeface="Calibri" pitchFamily="34" charset="0"/>
+                <a:ea typeface="Calibri" pitchFamily="34" charset="-122"/>
+                <a:cs typeface="Calibri" pitchFamily="34" charset="-120"/>
+              </a:rPr>
+              <a:t>Projeção baseada na média dos últimos 3 meses. A base termina em agosto de 2018.</a:t>
+            </a:r>
+            <a:endParaRPr lang="en-US" sz="1100" dirty="0"/>
           </a:p>
         </p:txBody>
       </p:sp>
@@ -2826,7 +3314,7 @@
           <a:bodyPr wrap="square" rtlCol="0" anchor="ctr"/>
           <a:lstStyle/>
           <a:p>
-            <a:pPr marL="0" indent="0">
+            <a:pPr indent="0" marL="0">
               <a:buNone/>
             </a:pPr>
             <a:r>
@@ -2838,7 +3326,7 @@
                 <a:ea typeface="Calibri" pitchFamily="34" charset="-122"/>
                 <a:cs typeface="Calibri" pitchFamily="34" charset="-120"/>
               </a:rPr>
-              <a:t>Uma limitação importante</a:t>
+              <a:t>Recomendações</a:t>
             </a:r>
             <a:endParaRPr lang="en-US" sz="3000" dirty="0"/>
           </a:p>
@@ -2881,7 +3369,7 @@
                 <a:ea typeface="Calibri" pitchFamily="34" charset="-122"/>
                 <a:cs typeface="Calibri" pitchFamily="34" charset="-120"/>
               </a:rPr>
-              <a:t>A base não informa quanto a Olist recebe de comissão em cada venda</a:t>
+              <a:t>Priorizar atração e retenção de clientes, que foi o lado que parou de crescer e trava a receita</a:t>
             </a:r>
             <a:endParaRPr lang="en-US" sz="2000" dirty="0"/>
           </a:p>
@@ -2902,7 +3390,7 @@
                 <a:ea typeface="Calibri" pitchFamily="34" charset="-122"/>
                 <a:cs typeface="Calibri" pitchFamily="34" charset="-120"/>
               </a:rPr>
-              <a:t>Por isso, a receita analisada aqui é o valor total da venda, e não o que entra no caixa da empresa</a:t>
+              <a:t>Crescer fora dos cinco maiores estados, que hoje concentram 73% da receita</a:t>
             </a:r>
             <a:endParaRPr lang="en-US" sz="2000" dirty="0"/>
           </a:p>
@@ -2923,7 +3411,7 @@
                 <a:ea typeface="Calibri" pitchFamily="34" charset="-122"/>
                 <a:cs typeface="Calibri" pitchFamily="34" charset="-120"/>
               </a:rPr>
-              <a:t>Isso significa que não é possível calcular lucro ou margem com esses dados</a:t>
+              <a:t>Acompanhar a receita por vendedor, que caiu quase um terço em oito meses</a:t>
             </a:r>
             <a:endParaRPr lang="en-US" sz="2000" dirty="0"/>
           </a:p>
@@ -2944,9 +3432,282 @@
                 <a:ea typeface="Calibri" pitchFamily="34" charset="-122"/>
                 <a:cs typeface="Calibri" pitchFamily="34" charset="-120"/>
               </a:rPr>
+              <a:t>Trabalhar o valor do pedido, já que o crescimento veio de volume e não de ticket maior</a:t>
+            </a:r>
+            <a:endParaRPr lang="en-US" sz="2000" dirty="0"/>
+          </a:p>
+        </p:txBody>
+      </p:sp>
+    </p:spTree>
+  </p:cSld>
+  <p:clrMapOvr>
+    <a:masterClrMapping/>
+  </p:clrMapOvr>
+</p:sld>
+</file>
+
+<file path=ppt/slides/slide15.xml><?xml version="1.0" encoding="utf-8"?>
+<p:sld xmlns:a="http://schemas.openxmlformats.org/drawingml/2006/main" xmlns:r="http://schemas.openxmlformats.org/officeDocument/2006/relationships" xmlns:p="http://schemas.openxmlformats.org/presentationml/2006/main">
+  <p:cSld name="Slide 15">
+    <p:spTree>
+      <p:nvGrpSpPr>
+        <p:cNvPr id="1" name=""/>
+        <p:cNvGrpSpPr/>
+        <p:nvPr/>
+      </p:nvGrpSpPr>
+      <p:grpSpPr>
+        <a:xfrm>
+          <a:off x="0" y="0"/>
+          <a:ext cx="0" cy="0"/>
+          <a:chOff x="0" y="0"/>
+          <a:chExt cx="0" cy="0"/>
+        </a:xfrm>
+      </p:grpSpPr>
+      <p:sp>
+        <p:nvSpPr>
+          <p:cNvPr id="2" name="Text 0"/>
+          <p:cNvSpPr/>
+          <p:nvPr/>
+        </p:nvSpPr>
+        <p:spPr>
+          <a:xfrm>
+            <a:off x="731520" y="548640"/>
+            <a:ext cx="10698480" cy="640080"/>
+          </a:xfrm>
+          <a:prstGeom prst="rect">
+            <a:avLst/>
+          </a:prstGeom>
+          <a:noFill/>
+          <a:ln/>
+        </p:spPr>
+        <p:txBody>
+          <a:bodyPr wrap="square" rtlCol="0" anchor="ctr"/>
+          <a:lstStyle/>
+          <a:p>
+            <a:pPr indent="0" marL="0">
+              <a:buNone/>
+            </a:pPr>
+            <a:r>
+              <a:rPr lang="en-US" sz="3000" b="1" dirty="0">
+                <a:solidFill>
+                  <a:srgbClr val="1F4E79"/>
+                </a:solidFill>
+                <a:latin typeface="Calibri" pitchFamily="34" charset="0"/>
+                <a:ea typeface="Calibri" pitchFamily="34" charset="-122"/>
+                <a:cs typeface="Calibri" pitchFamily="34" charset="-120"/>
+              </a:rPr>
+              <a:t>Uma limitação importante</a:t>
+            </a:r>
+            <a:endParaRPr lang="en-US" sz="3000" dirty="0"/>
+          </a:p>
+        </p:txBody>
+      </p:sp>
+      <p:sp>
+        <p:nvSpPr>
+          <p:cNvPr id="3" name="Text 1"/>
+          <p:cNvSpPr/>
+          <p:nvPr/>
+        </p:nvSpPr>
+        <p:spPr>
+          <a:xfrm>
+            <a:off x="914400" y="1554480"/>
+            <a:ext cx="10332720" cy="4389120"/>
+          </a:xfrm>
+          <a:prstGeom prst="rect">
+            <a:avLst/>
+          </a:prstGeom>
+          <a:noFill/>
+          <a:ln/>
+        </p:spPr>
+        <p:txBody>
+          <a:bodyPr wrap="square" rtlCol="0" anchor="ctr"/>
+          <a:lstStyle/>
+          <a:p>
+            <a:pPr marL="342900" indent="-342900">
+              <a:lnSpc>
+                <a:spcPct val="140000"/>
+              </a:lnSpc>
+              <a:buSzPct val="100000"/>
+              <a:buChar char="•"/>
+            </a:pPr>
+            <a:r>
+              <a:rPr lang="en-US" sz="2000" dirty="0">
+                <a:solidFill>
+                  <a:srgbClr val="404040"/>
+                </a:solidFill>
+                <a:latin typeface="Calibri" pitchFamily="34" charset="0"/>
+                <a:ea typeface="Calibri" pitchFamily="34" charset="-122"/>
+                <a:cs typeface="Calibri" pitchFamily="34" charset="-120"/>
+              </a:rPr>
+              <a:t>A base não informa quanto a Olist recebe de comissão em cada venda</a:t>
+            </a:r>
+            <a:endParaRPr lang="en-US" sz="2000" dirty="0"/>
+          </a:p>
+          <a:p>
+            <a:pPr marL="342900" indent="-342900">
+              <a:lnSpc>
+                <a:spcPct val="140000"/>
+              </a:lnSpc>
+              <a:buSzPct val="100000"/>
+              <a:buChar char="•"/>
+            </a:pPr>
+            <a:r>
+              <a:rPr lang="en-US" sz="2000" dirty="0">
+                <a:solidFill>
+                  <a:srgbClr val="404040"/>
+                </a:solidFill>
+                <a:latin typeface="Calibri" pitchFamily="34" charset="0"/>
+                <a:ea typeface="Calibri" pitchFamily="34" charset="-122"/>
+                <a:cs typeface="Calibri" pitchFamily="34" charset="-120"/>
+              </a:rPr>
+              <a:t>Por isso, a receita analisada aqui é o valor total da venda, e não o que entra no caixa da empresa</a:t>
+            </a:r>
+            <a:endParaRPr lang="en-US" sz="2000" dirty="0"/>
+          </a:p>
+          <a:p>
+            <a:pPr marL="342900" indent="-342900">
+              <a:lnSpc>
+                <a:spcPct val="140000"/>
+              </a:lnSpc>
+              <a:buSzPct val="100000"/>
+              <a:buChar char="•"/>
+            </a:pPr>
+            <a:r>
+              <a:rPr lang="en-US" sz="2000" dirty="0">
+                <a:solidFill>
+                  <a:srgbClr val="404040"/>
+                </a:solidFill>
+                <a:latin typeface="Calibri" pitchFamily="34" charset="0"/>
+                <a:ea typeface="Calibri" pitchFamily="34" charset="-122"/>
+                <a:cs typeface="Calibri" pitchFamily="34" charset="-120"/>
+              </a:rPr>
+              <a:t>Isso significa que não é possível calcular lucro ou margem com esses dados</a:t>
+            </a:r>
+            <a:endParaRPr lang="en-US" sz="2000" dirty="0"/>
+          </a:p>
+          <a:p>
+            <a:pPr marL="342900" indent="-342900">
+              <a:lnSpc>
+                <a:spcPct val="140000"/>
+              </a:lnSpc>
+              <a:buSzPct val="100000"/>
+              <a:buChar char="•"/>
+            </a:pPr>
+            <a:r>
+              <a:rPr lang="en-US" sz="2000" dirty="0">
+                <a:solidFill>
+                  <a:srgbClr val="404040"/>
+                </a:solidFill>
+                <a:latin typeface="Calibri" pitchFamily="34" charset="0"/>
+                <a:ea typeface="Calibri" pitchFamily="34" charset="-122"/>
+                <a:cs typeface="Calibri" pitchFamily="34" charset="-120"/>
+              </a:rPr>
               <a:t>As conclusões se limitam a volume de vendas, receita e concentração</a:t>
             </a:r>
             <a:endParaRPr lang="en-US" sz="2000" dirty="0"/>
+          </a:p>
+        </p:txBody>
+      </p:sp>
+    </p:spTree>
+  </p:cSld>
+  <p:clrMapOvr>
+    <a:masterClrMapping/>
+  </p:clrMapOvr>
+</p:sld>
+</file>
+
+<file path=ppt/slides/slide16.xml><?xml version="1.0" encoding="utf-8"?>
+<p:sld xmlns:a="http://schemas.openxmlformats.org/drawingml/2006/main" xmlns:r="http://schemas.openxmlformats.org/officeDocument/2006/relationships" xmlns:p="http://schemas.openxmlformats.org/presentationml/2006/main">
+  <p:cSld name="Slide 16">
+    <p:spTree>
+      <p:nvGrpSpPr>
+        <p:cNvPr id="1" name=""/>
+        <p:cNvGrpSpPr/>
+        <p:nvPr/>
+      </p:nvGrpSpPr>
+      <p:grpSpPr>
+        <a:xfrm>
+          <a:off x="0" y="0"/>
+          <a:ext cx="0" cy="0"/>
+          <a:chOff x="0" y="0"/>
+          <a:chExt cx="0" cy="0"/>
+        </a:xfrm>
+      </p:grpSpPr>
+      <p:sp>
+        <p:nvSpPr>
+          <p:cNvPr id="2" name="Text 0"/>
+          <p:cNvSpPr/>
+          <p:nvPr/>
+        </p:nvSpPr>
+        <p:spPr>
+          <a:xfrm>
+            <a:off x="0" y="2743200"/>
+            <a:ext cx="12188952" cy="822960"/>
+          </a:xfrm>
+          <a:prstGeom prst="rect">
+            <a:avLst/>
+          </a:prstGeom>
+          <a:noFill/>
+          <a:ln/>
+        </p:spPr>
+        <p:txBody>
+          <a:bodyPr wrap="square" rtlCol="0" anchor="ctr"/>
+          <a:lstStyle/>
+          <a:p>
+            <a:pPr algn="ctr" indent="0" marL="0">
+              <a:buNone/>
+            </a:pPr>
+            <a:r>
+              <a:rPr lang="en-US" sz="3600" b="1" dirty="0">
+                <a:solidFill>
+                  <a:srgbClr val="1F4E79"/>
+                </a:solidFill>
+                <a:latin typeface="Calibri" pitchFamily="34" charset="0"/>
+                <a:ea typeface="Calibri" pitchFamily="34" charset="-122"/>
+                <a:cs typeface="Calibri" pitchFamily="34" charset="-120"/>
+              </a:rPr>
+              <a:t>Obrigado</a:t>
+            </a:r>
+            <a:endParaRPr lang="en-US" sz="3600" dirty="0"/>
+          </a:p>
+        </p:txBody>
+      </p:sp>
+      <p:sp>
+        <p:nvSpPr>
+          <p:cNvPr id="3" name="Text 1"/>
+          <p:cNvSpPr/>
+          <p:nvPr/>
+        </p:nvSpPr>
+        <p:spPr>
+          <a:xfrm>
+            <a:off x="0" y="3566160"/>
+            <a:ext cx="12188952" cy="457200"/>
+          </a:xfrm>
+          <a:prstGeom prst="rect">
+            <a:avLst/>
+          </a:prstGeom>
+          <a:noFill/>
+          <a:ln/>
+        </p:spPr>
+        <p:txBody>
+          <a:bodyPr wrap="square" rtlCol="0" anchor="ctr"/>
+          <a:lstStyle/>
+          <a:p>
+            <a:pPr algn="ctr" indent="0" marL="0">
+              <a:buNone/>
+            </a:pPr>
+            <a:r>
+              <a:rPr lang="en-US" sz="1600" dirty="0">
+                <a:solidFill>
+                  <a:srgbClr val="404040"/>
+                </a:solidFill>
+                <a:latin typeface="Calibri" pitchFamily="34" charset="0"/>
+                <a:ea typeface="Calibri" pitchFamily="34" charset="-122"/>
+                <a:cs typeface="Calibri" pitchFamily="34" charset="-120"/>
+              </a:rPr>
+              <a:t>Evanio Alves Carvalho | Tech Challenge Fase 1</a:t>
+            </a:r>
+            <a:endParaRPr lang="en-US" sz="1600" dirty="0"/>
           </a:p>
         </p:txBody>
       </p:sp>
@@ -2996,7 +3757,7 @@
           <a:bodyPr wrap="square" rtlCol="0" anchor="ctr"/>
           <a:lstStyle/>
           <a:p>
-            <a:pPr marL="0" indent="0">
+            <a:pPr indent="0" marL="0">
               <a:buNone/>
             </a:pPr>
             <a:r>
@@ -3187,7 +3948,7 @@
           <a:bodyPr wrap="square" rtlCol="0" anchor="ctr"/>
           <a:lstStyle/>
           <a:p>
-            <a:pPr marL="0" indent="0">
+            <a:pPr indent="0" marL="0">
               <a:buNone/>
             </a:pPr>
             <a:r>
@@ -3378,7 +4139,7 @@
           <a:bodyPr wrap="square" rtlCol="0" anchor="ctr"/>
           <a:lstStyle/>
           <a:p>
-            <a:pPr marL="0" indent="0">
+            <a:pPr indent="0" marL="0">
               <a:buNone/>
             </a:pPr>
             <a:r>
@@ -3412,27 +4173,15 @@
         </p:nvGraphicFramePr>
         <p:xfrm>
           <a:off x="1463040" y="1645920"/>
-          <a:ext cx="9144000" cy="3520440"/>
+          <a:ext cx="9144000" cy="914400"/>
         </p:xfrm>
         <a:graphic>
           <a:graphicData uri="http://schemas.openxmlformats.org/drawingml/2006/table">
             <a:tbl>
               <a:tblPr/>
               <a:tblGrid>
-                <a:gridCol w="4572000">
-                  <a:extLst>
-                    <a:ext uri="{9D8B030D-6E8A-4147-A177-3AD203B41FA5}">
-                      <a16:colId xmlns:a16="http://schemas.microsoft.com/office/drawing/2014/main" val="20000"/>
-                    </a:ext>
-                  </a:extLst>
-                </a:gridCol>
-                <a:gridCol w="4572000">
-                  <a:extLst>
-                    <a:ext uri="{9D8B030D-6E8A-4147-A177-3AD203B41FA5}">
-                      <a16:colId xmlns:a16="http://schemas.microsoft.com/office/drawing/2014/main" val="20001"/>
-                    </a:ext>
-                  </a:extLst>
-                </a:gridCol>
+                <a:gridCol w="4572000"/>
+                <a:gridCol w="4572000"/>
               </a:tblGrid>
               <a:tr h="502920">
                 <a:tc>
@@ -3440,7 +4189,7 @@
                     <a:bodyPr/>
                     <a:lstStyle/>
                     <a:p>
-                      <a:pPr marL="0" indent="0">
+                      <a:pPr indent="0" marL="0">
                         <a:buNone/>
                       </a:pPr>
                       <a:r>
@@ -3461,7 +4210,7 @@
                       </a:endParaRPr>
                     </a:p>
                   </a:txBody>
-                  <a:tcPr>
+                  <a:tcPr marL="91440" marR="91440" marT="45720" marB="45720">
                     <a:lnL w="12700" cap="flat" cmpd="sng" algn="ctr">
                       <a:solidFill>
                         <a:srgbClr val="D9D9D9"/>
@@ -3508,7 +4257,7 @@
                     <a:bodyPr/>
                     <a:lstStyle/>
                     <a:p>
-                      <a:pPr marL="0" indent="0">
+                      <a:pPr indent="0" marL="0">
                         <a:buNone/>
                       </a:pPr>
                       <a:r>
@@ -3529,7 +4278,7 @@
                       </a:endParaRPr>
                     </a:p>
                   </a:txBody>
-                  <a:tcPr>
+                  <a:tcPr marL="91440" marR="91440" marT="45720" marB="45720">
                     <a:lnL w="12700" cap="flat" cmpd="sng" algn="ctr">
                       <a:solidFill>
                         <a:srgbClr val="D9D9D9"/>
@@ -3571,11 +4320,6 @@
                     </a:solidFill>
                   </a:tcPr>
                 </a:tc>
-                <a:extLst>
-                  <a:ext uri="{0D108BD9-81ED-4DB2-BD59-A6C34878D82A}">
-                    <a16:rowId xmlns:a16="http://schemas.microsoft.com/office/drawing/2014/main" val="10000"/>
-                  </a:ext>
-                </a:extLst>
               </a:tr>
               <a:tr h="502920">
                 <a:tc>
@@ -3583,7 +4327,7 @@
                     <a:bodyPr/>
                     <a:lstStyle/>
                     <a:p>
-                      <a:pPr marL="0" indent="0">
+                      <a:pPr indent="0" marL="0">
                         <a:buNone/>
                       </a:pPr>
                       <a:r>
@@ -3604,7 +4348,7 @@
                       </a:endParaRPr>
                     </a:p>
                   </a:txBody>
-                  <a:tcPr>
+                  <a:tcPr marL="91440" marR="91440" marT="45720" marB="45720">
                     <a:lnL w="12700" cap="flat" cmpd="sng" algn="ctr">
                       <a:solidFill>
                         <a:srgbClr val="D9D9D9"/>
@@ -3648,7 +4392,7 @@
                     <a:bodyPr/>
                     <a:lstStyle/>
                     <a:p>
-                      <a:pPr marL="0" indent="0">
+                      <a:pPr indent="0" marL="0">
                         <a:buNone/>
                       </a:pPr>
                       <a:r>
@@ -3669,7 +4413,7 @@
                       </a:endParaRPr>
                     </a:p>
                   </a:txBody>
-                  <a:tcPr>
+                  <a:tcPr marL="91440" marR="91440" marT="45720" marB="45720">
                     <a:lnL w="12700" cap="flat" cmpd="sng" algn="ctr">
                       <a:solidFill>
                         <a:srgbClr val="D9D9D9"/>
@@ -3708,11 +4452,6 @@
                     </a:lnB>
                   </a:tcPr>
                 </a:tc>
-                <a:extLst>
-                  <a:ext uri="{0D108BD9-81ED-4DB2-BD59-A6C34878D82A}">
-                    <a16:rowId xmlns:a16="http://schemas.microsoft.com/office/drawing/2014/main" val="10001"/>
-                  </a:ext>
-                </a:extLst>
               </a:tr>
               <a:tr h="502920">
                 <a:tc>
@@ -3720,7 +4459,7 @@
                     <a:bodyPr/>
                     <a:lstStyle/>
                     <a:p>
-                      <a:pPr marL="0" indent="0">
+                      <a:pPr indent="0" marL="0">
                         <a:buNone/>
                       </a:pPr>
                       <a:r>
@@ -3741,7 +4480,7 @@
                       </a:endParaRPr>
                     </a:p>
                   </a:txBody>
-                  <a:tcPr>
+                  <a:tcPr marL="91440" marR="91440" marT="45720" marB="45720">
                     <a:lnL w="12700" cap="flat" cmpd="sng" algn="ctr">
                       <a:solidFill>
                         <a:srgbClr val="D9D9D9"/>
@@ -3785,7 +4524,7 @@
                     <a:bodyPr/>
                     <a:lstStyle/>
                     <a:p>
-                      <a:pPr marL="0" indent="0">
+                      <a:pPr indent="0" marL="0">
                         <a:buNone/>
                       </a:pPr>
                       <a:r>
@@ -3806,7 +4545,7 @@
                       </a:endParaRPr>
                     </a:p>
                   </a:txBody>
-                  <a:tcPr>
+                  <a:tcPr marL="91440" marR="91440" marT="45720" marB="45720">
                     <a:lnL w="12700" cap="flat" cmpd="sng" algn="ctr">
                       <a:solidFill>
                         <a:srgbClr val="D9D9D9"/>
@@ -3845,11 +4584,6 @@
                     </a:lnB>
                   </a:tcPr>
                 </a:tc>
-                <a:extLst>
-                  <a:ext uri="{0D108BD9-81ED-4DB2-BD59-A6C34878D82A}">
-                    <a16:rowId xmlns:a16="http://schemas.microsoft.com/office/drawing/2014/main" val="10002"/>
-                  </a:ext>
-                </a:extLst>
               </a:tr>
               <a:tr h="502920">
                 <a:tc>
@@ -3857,7 +4591,7 @@
                     <a:bodyPr/>
                     <a:lstStyle/>
                     <a:p>
-                      <a:pPr marL="0" indent="0">
+                      <a:pPr indent="0" marL="0">
                         <a:buNone/>
                       </a:pPr>
                       <a:r>
@@ -3878,7 +4612,7 @@
                       </a:endParaRPr>
                     </a:p>
                   </a:txBody>
-                  <a:tcPr>
+                  <a:tcPr marL="91440" marR="91440" marT="45720" marB="45720">
                     <a:lnL w="12700" cap="flat" cmpd="sng" algn="ctr">
                       <a:solidFill>
                         <a:srgbClr val="D9D9D9"/>
@@ -3922,7 +4656,7 @@
                     <a:bodyPr/>
                     <a:lstStyle/>
                     <a:p>
-                      <a:pPr marL="0" indent="0">
+                      <a:pPr indent="0" marL="0">
                         <a:buNone/>
                       </a:pPr>
                       <a:r>
@@ -3943,7 +4677,7 @@
                       </a:endParaRPr>
                     </a:p>
                   </a:txBody>
-                  <a:tcPr>
+                  <a:tcPr marL="91440" marR="91440" marT="45720" marB="45720">
                     <a:lnL w="12700" cap="flat" cmpd="sng" algn="ctr">
                       <a:solidFill>
                         <a:srgbClr val="D9D9D9"/>
@@ -3982,11 +4716,6 @@
                     </a:lnB>
                   </a:tcPr>
                 </a:tc>
-                <a:extLst>
-                  <a:ext uri="{0D108BD9-81ED-4DB2-BD59-A6C34878D82A}">
-                    <a16:rowId xmlns:a16="http://schemas.microsoft.com/office/drawing/2014/main" val="10003"/>
-                  </a:ext>
-                </a:extLst>
               </a:tr>
               <a:tr h="502920">
                 <a:tc>
@@ -3994,7 +4723,7 @@
                     <a:bodyPr/>
                     <a:lstStyle/>
                     <a:p>
-                      <a:pPr marL="0" indent="0">
+                      <a:pPr indent="0" marL="0">
                         <a:buNone/>
                       </a:pPr>
                       <a:r>
@@ -4015,7 +4744,7 @@
                       </a:endParaRPr>
                     </a:p>
                   </a:txBody>
-                  <a:tcPr>
+                  <a:tcPr marL="91440" marR="91440" marT="45720" marB="45720">
                     <a:lnL w="12700" cap="flat" cmpd="sng" algn="ctr">
                       <a:solidFill>
                         <a:srgbClr val="D9D9D9"/>
@@ -4059,7 +4788,7 @@
                     <a:bodyPr/>
                     <a:lstStyle/>
                     <a:p>
-                      <a:pPr marL="0" indent="0">
+                      <a:pPr indent="0" marL="0">
                         <a:buNone/>
                       </a:pPr>
                       <a:r>
@@ -4080,7 +4809,7 @@
                       </a:endParaRPr>
                     </a:p>
                   </a:txBody>
-                  <a:tcPr>
+                  <a:tcPr marL="91440" marR="91440" marT="45720" marB="45720">
                     <a:lnL w="12700" cap="flat" cmpd="sng" algn="ctr">
                       <a:solidFill>
                         <a:srgbClr val="D9D9D9"/>
@@ -4119,11 +4848,6 @@
                     </a:lnB>
                   </a:tcPr>
                 </a:tc>
-                <a:extLst>
-                  <a:ext uri="{0D108BD9-81ED-4DB2-BD59-A6C34878D82A}">
-                    <a16:rowId xmlns:a16="http://schemas.microsoft.com/office/drawing/2014/main" val="10004"/>
-                  </a:ext>
-                </a:extLst>
               </a:tr>
               <a:tr h="502920">
                 <a:tc>
@@ -4131,7 +4855,7 @@
                     <a:bodyPr/>
                     <a:lstStyle/>
                     <a:p>
-                      <a:pPr marL="0" indent="0">
+                      <a:pPr indent="0" marL="0">
                         <a:buNone/>
                       </a:pPr>
                       <a:r>
@@ -4152,7 +4876,7 @@
                       </a:endParaRPr>
                     </a:p>
                   </a:txBody>
-                  <a:tcPr>
+                  <a:tcPr marL="91440" marR="91440" marT="45720" marB="45720">
                     <a:lnL w="12700" cap="flat" cmpd="sng" algn="ctr">
                       <a:solidFill>
                         <a:srgbClr val="D9D9D9"/>
@@ -4196,7 +4920,7 @@
                     <a:bodyPr/>
                     <a:lstStyle/>
                     <a:p>
-                      <a:pPr marL="0" indent="0">
+                      <a:pPr indent="0" marL="0">
                         <a:buNone/>
                       </a:pPr>
                       <a:r>
@@ -4217,7 +4941,7 @@
                       </a:endParaRPr>
                     </a:p>
                   </a:txBody>
-                  <a:tcPr>
+                  <a:tcPr marL="91440" marR="91440" marT="45720" marB="45720">
                     <a:lnL w="12700" cap="flat" cmpd="sng" algn="ctr">
                       <a:solidFill>
                         <a:srgbClr val="D9D9D9"/>
@@ -4256,11 +4980,6 @@
                     </a:lnB>
                   </a:tcPr>
                 </a:tc>
-                <a:extLst>
-                  <a:ext uri="{0D108BD9-81ED-4DB2-BD59-A6C34878D82A}">
-                    <a16:rowId xmlns:a16="http://schemas.microsoft.com/office/drawing/2014/main" val="10005"/>
-                  </a:ext>
-                </a:extLst>
               </a:tr>
               <a:tr h="502920">
                 <a:tc>
@@ -4268,7 +4987,7 @@
                     <a:bodyPr/>
                     <a:lstStyle/>
                     <a:p>
-                      <a:pPr marL="0" indent="0">
+                      <a:pPr indent="0" marL="0">
                         <a:buNone/>
                       </a:pPr>
                       <a:r>
@@ -4289,7 +5008,7 @@
                       </a:endParaRPr>
                     </a:p>
                   </a:txBody>
-                  <a:tcPr>
+                  <a:tcPr marL="91440" marR="91440" marT="45720" marB="45720">
                     <a:lnL w="12700" cap="flat" cmpd="sng" algn="ctr">
                       <a:solidFill>
                         <a:srgbClr val="D9D9D9"/>
@@ -4333,7 +5052,7 @@
                     <a:bodyPr/>
                     <a:lstStyle/>
                     <a:p>
-                      <a:pPr marL="0" indent="0">
+                      <a:pPr indent="0" marL="0">
                         <a:buNone/>
                       </a:pPr>
                       <a:r>
@@ -4354,7 +5073,7 @@
                       </a:endParaRPr>
                     </a:p>
                   </a:txBody>
-                  <a:tcPr>
+                  <a:tcPr marL="91440" marR="91440" marT="45720" marB="45720">
                     <a:lnL w="12700" cap="flat" cmpd="sng" algn="ctr">
                       <a:solidFill>
                         <a:srgbClr val="D9D9D9"/>
@@ -4393,11 +5112,6 @@
                     </a:lnB>
                   </a:tcPr>
                 </a:tc>
-                <a:extLst>
-                  <a:ext uri="{0D108BD9-81ED-4DB2-BD59-A6C34878D82A}">
-                    <a16:rowId xmlns:a16="http://schemas.microsoft.com/office/drawing/2014/main" val="10006"/>
-                  </a:ext>
-                </a:extLst>
               </a:tr>
             </a:tbl>
           </a:graphicData>
@@ -4449,7 +5163,7 @@
           <a:bodyPr wrap="square" rtlCol="0" anchor="ctr"/>
           <a:lstStyle/>
           <a:p>
-            <a:pPr marL="0" indent="0">
+            <a:pPr indent="0" marL="0">
               <a:buNone/>
             </a:pPr>
             <a:r>
@@ -4469,15 +5183,15 @@
       </p:sp>
       <p:pic>
         <p:nvPicPr>
-          <p:cNvPr id="3" name="Image 0" descr="/sessions/nice-great-mayer/mnt/outputs/pptx_project/assets_simples/chart_00_serie_completa.png"/>
+          <p:cNvPr id="3" name="Image 0" descr="/sessions/nice-great-mayer/mnt/outputs/pptx_project/assets_simples/chart_00_serie_completa.png">    </p:cNvPr>
           <p:cNvPicPr>
             <a:picLocks noChangeAspect="1"/>
           </p:cNvPicPr>
           <p:nvPr/>
         </p:nvPicPr>
         <p:blipFill>
-          <a:blip r:embed="rId3"/>
-          <a:srcRect/>
+          <a:blip r:embed="rId1"/>
+          <a:srcRect l="0" r="0" t="0" b="0"/>
           <a:stretch/>
         </p:blipFill>
         <p:spPr>
@@ -4617,7 +5331,7 @@
           <a:bodyPr wrap="square" rtlCol="0" anchor="ctr"/>
           <a:lstStyle/>
           <a:p>
-            <a:pPr marL="0" indent="0">
+            <a:pPr indent="0" marL="0">
               <a:buNone/>
             </a:pPr>
             <a:r>
@@ -4681,7 +5395,7 @@
           <a:bodyPr wrap="square" rtlCol="0" anchor="ctr"/>
           <a:lstStyle/>
           <a:p>
-            <a:pPr marL="0" indent="0">
+            <a:pPr indent="0" marL="0">
               <a:buNone/>
             </a:pPr>
             <a:r>
@@ -4701,15 +5415,15 @@
       </p:sp>
       <p:pic>
         <p:nvPicPr>
-          <p:cNvPr id="3" name="Image 0" descr="/sessions/nice-great-mayer/mnt/outputs/pptx_project/assets_simples/chart_01_evolucao_mensal.png"/>
+          <p:cNvPr id="3" name="Image 0" descr="/sessions/nice-great-mayer/mnt/outputs/pptx_project/assets_simples/chart_01_evolucao_mensal.png">    </p:cNvPr>
           <p:cNvPicPr>
             <a:picLocks noChangeAspect="1"/>
           </p:cNvPicPr>
           <p:nvPr/>
         </p:nvPicPr>
         <p:blipFill>
-          <a:blip r:embed="rId3"/>
-          <a:srcRect/>
+          <a:blip r:embed="rId1"/>
+          <a:srcRect l="0" r="0" t="0" b="0"/>
           <a:stretch/>
         </p:blipFill>
         <p:spPr>
@@ -4828,7 +5542,7 @@
           <a:bodyPr wrap="square" rtlCol="0" anchor="ctr"/>
           <a:lstStyle/>
           <a:p>
-            <a:pPr marL="0" indent="0">
+            <a:pPr indent="0" marL="0">
               <a:buNone/>
             </a:pPr>
             <a:r>
@@ -4892,7 +5606,7 @@
           <a:bodyPr wrap="square" rtlCol="0" anchor="ctr"/>
           <a:lstStyle/>
           <a:p>
-            <a:pPr marL="0" indent="0">
+            <a:pPr indent="0" marL="0">
               <a:buNone/>
             </a:pPr>
             <a:r>
@@ -4912,15 +5626,15 @@
       </p:sp>
       <p:pic>
         <p:nvPicPr>
-          <p:cNvPr id="3" name="Image 0" descr="/sessions/nice-great-mayer/mnt/outputs/pptx_project/assets_simples/chart_07_black_friday.png"/>
+          <p:cNvPr id="3" name="Image 0" descr="/sessions/nice-great-mayer/mnt/outputs/pptx_project/assets_simples/chart_07_black_friday.png">    </p:cNvPr>
           <p:cNvPicPr>
             <a:picLocks noChangeAspect="1"/>
           </p:cNvPicPr>
           <p:nvPr/>
         </p:nvPicPr>
         <p:blipFill>
-          <a:blip r:embed="rId3"/>
-          <a:srcRect/>
+          <a:blip r:embed="rId1"/>
+          <a:srcRect l="0" r="0" t="0" b="0"/>
           <a:stretch/>
         </p:blipFill>
         <p:spPr>
@@ -5039,7 +5753,7 @@
           <a:bodyPr wrap="square" rtlCol="0" anchor="ctr"/>
           <a:lstStyle/>
           <a:p>
-            <a:pPr marL="0" indent="0">
+            <a:pPr indent="0" marL="0">
               <a:buNone/>
             </a:pPr>
             <a:r>
@@ -5103,7 +5817,7 @@
           <a:bodyPr wrap="square" rtlCol="0" anchor="ctr"/>
           <a:lstStyle/>
           <a:p>
-            <a:pPr marL="0" indent="0">
+            <a:pPr indent="0" marL="0">
               <a:buNone/>
             </a:pPr>
             <a:r>
@@ -5123,15 +5837,15 @@
       </p:sp>
       <p:pic>
         <p:nvPicPr>
-          <p:cNvPr id="3" name="Image 0" descr="/sessions/nice-great-mayer/mnt/outputs/pptx_project/assets_simples/chart_02_ticket_medio.png"/>
+          <p:cNvPr id="3" name="Image 0" descr="/sessions/nice-great-mayer/mnt/outputs/pptx_project/assets_simples/chart_02_ticket_medio.png">    </p:cNvPr>
           <p:cNvPicPr>
             <a:picLocks noChangeAspect="1"/>
           </p:cNvPicPr>
           <p:nvPr/>
         </p:nvPicPr>
         <p:blipFill>
-          <a:blip r:embed="rId3"/>
-          <a:srcRect/>
+          <a:blip r:embed="rId1"/>
+          <a:srcRect l="0" r="0" t="0" b="0"/>
           <a:stretch/>
         </p:blipFill>
         <p:spPr>
@@ -5250,7 +5964,7 @@
           <a:bodyPr wrap="square" rtlCol="0" anchor="ctr"/>
           <a:lstStyle/>
           <a:p>
-            <a:pPr marL="0" indent="0">
+            <a:pPr indent="0" marL="0">
               <a:buNone/>
             </a:pPr>
             <a:r>
@@ -5314,7 +6028,7 @@
           <a:bodyPr wrap="square" rtlCol="0" anchor="ctr"/>
           <a:lstStyle/>
           <a:p>
-            <a:pPr marL="0" indent="0">
+            <a:pPr indent="0" marL="0">
               <a:buNone/>
             </a:pPr>
             <a:r>
@@ -5334,15 +6048,15 @@
       </p:sp>
       <p:pic>
         <p:nvPicPr>
-          <p:cNvPr id="3" name="Image 0" descr="/sessions/nice-great-mayer/mnt/outputs/pptx_project/assets_simples/chart_03_top_categorias.png"/>
+          <p:cNvPr id="3" name="Image 0" descr="/sessions/nice-great-mayer/mnt/outputs/pptx_project/assets_simples/chart_03_top_categorias.png">    </p:cNvPr>
           <p:cNvPicPr>
             <a:picLocks noChangeAspect="1"/>
           </p:cNvPicPr>
           <p:nvPr/>
         </p:nvPicPr>
         <p:blipFill>
-          <a:blip r:embed="rId3"/>
-          <a:srcRect/>
+          <a:blip r:embed="rId1"/>
+          <a:srcRect l="0" r="0" t="0" b="0"/>
           <a:stretch/>
         </p:blipFill>
         <p:spPr>
@@ -5461,7 +6175,7 @@
           <a:bodyPr wrap="square" rtlCol="0" anchor="ctr"/>
           <a:lstStyle/>
           <a:p>
-            <a:pPr marL="0" indent="0">
+            <a:pPr indent="0" marL="0">
               <a:buNone/>
             </a:pPr>
             <a:r>
@@ -5780,319 +6494,4 @@
     </a:ext>
   </a:extLst>
 </a:theme>
-</file>
-
-<file path=ppt/theme/theme2.xml><?xml version="1.0" encoding="utf-8"?>
-<a:theme xmlns:a="http://schemas.openxmlformats.org/drawingml/2006/main" name="Tema do Office">
-  <a:themeElements>
-    <a:clrScheme name="Office">
-      <a:dk1>
-        <a:sysClr val="windowText" lastClr="000000"/>
-      </a:dk1>
-      <a:lt1>
-        <a:sysClr val="window" lastClr="FFFFFF"/>
-      </a:lt1>
-      <a:dk2>
-        <a:srgbClr val="0E2841"/>
-      </a:dk2>
-      <a:lt2>
-        <a:srgbClr val="E8E8E8"/>
-      </a:lt2>
-      <a:accent1>
-        <a:srgbClr val="156082"/>
-      </a:accent1>
-      <a:accent2>
-        <a:srgbClr val="E97132"/>
-      </a:accent2>
-      <a:accent3>
-        <a:srgbClr val="196B24"/>
-      </a:accent3>
-      <a:accent4>
-        <a:srgbClr val="0F9ED5"/>
-      </a:accent4>
-      <a:accent5>
-        <a:srgbClr val="A02B93"/>
-      </a:accent5>
-      <a:accent6>
-        <a:srgbClr val="4EA72E"/>
-      </a:accent6>
-      <a:hlink>
-        <a:srgbClr val="467886"/>
-      </a:hlink>
-      <a:folHlink>
-        <a:srgbClr val="96607D"/>
-      </a:folHlink>
-    </a:clrScheme>
-    <a:fontScheme name="Office">
-      <a:majorFont>
-        <a:latin typeface="Aptos Display" panose="02110004020202020204"/>
-        <a:ea typeface=""/>
-        <a:cs typeface=""/>
-        <a:font script="Jpan" typeface="游ゴシック Light"/>
-        <a:font script="Hang" typeface="맑은 고딕"/>
-        <a:font script="Hans" typeface="等线 Light"/>
-        <a:font script="Hant" typeface="新細明體"/>
-        <a:font script="Arab" typeface="Times New Roman"/>
-        <a:font script="Hebr" typeface="Times New Roman"/>
-        <a:font script="Thai" typeface="Angsana New"/>
-        <a:font script="Ethi" typeface="Nyala"/>
-        <a:font script="Beng" typeface="Vrinda"/>
-        <a:font script="Gujr" typeface="Shruti"/>
-        <a:font script="Khmr" typeface="MoolBoran"/>
-        <a:font script="Knda" typeface="Tunga"/>
-        <a:font script="Guru" typeface="Raavi"/>
-        <a:font script="Cans" typeface="Euphemia"/>
-        <a:font script="Cher" typeface="Plantagenet Cherokee"/>
-        <a:font script="Yiii" typeface="Microsoft Yi Baiti"/>
-        <a:font script="Tibt" typeface="Microsoft Himalaya"/>
-        <a:font script="Thaa" typeface="MV Boli"/>
-        <a:font script="Deva" typeface="Mangal"/>
-        <a:font script="Telu" typeface="Gautami"/>
-        <a:font script="Taml" typeface="Latha"/>
-        <a:font script="Syrc" typeface="Estrangelo Edessa"/>
-        <a:font script="Orya" typeface="Kalinga"/>
-        <a:font script="Mlym" typeface="Kartika"/>
-        <a:font script="Laoo" typeface="DokChampa"/>
-        <a:font script="Sinh" typeface="Iskoola Pota"/>
-        <a:font script="Mong" typeface="Mongolian Baiti"/>
-        <a:font script="Viet" typeface="Times New Roman"/>
-        <a:font script="Uigh" typeface="Microsoft Uighur"/>
-        <a:font script="Geor" typeface="Sylfaen"/>
-        <a:font script="Armn" typeface="Arial"/>
-        <a:font script="Bugi" typeface="Leelawadee UI"/>
-        <a:font script="Bopo" typeface="Microsoft JhengHei"/>
-        <a:font script="Java" typeface="Javanese Text"/>
-        <a:font script="Lisu" typeface="Segoe UI"/>
-        <a:font script="Mymr" typeface="Myanmar Text"/>
-        <a:font script="Nkoo" typeface="Ebrima"/>
-        <a:font script="Olck" typeface="Nirmala UI"/>
-        <a:font script="Osma" typeface="Ebrima"/>
-        <a:font script="Phag" typeface="Phagspa"/>
-        <a:font script="Syrn" typeface="Estrangelo Edessa"/>
-        <a:font script="Syrj" typeface="Estrangelo Edessa"/>
-        <a:font script="Syre" typeface="Estrangelo Edessa"/>
-        <a:font script="Sora" typeface="Nirmala UI"/>
-        <a:font script="Tale" typeface="Microsoft Tai Le"/>
-        <a:font script="Talu" typeface="Microsoft New Tai Lue"/>
-        <a:font script="Tfng" typeface="Ebrima"/>
-      </a:majorFont>
-      <a:minorFont>
-        <a:latin typeface="Aptos" panose="02110004020202020204"/>
-        <a:ea typeface=""/>
-        <a:cs typeface=""/>
-        <a:font script="Jpan" typeface="游ゴシック"/>
-        <a:font script="Hang" typeface="맑은 고딕"/>
-        <a:font script="Hans" typeface="等线"/>
-        <a:font script="Hant" typeface="新細明體"/>
-        <a:font script="Arab" typeface="Arial"/>
-        <a:font script="Hebr" typeface="Arial"/>
-        <a:font script="Thai" typeface="Cordia New"/>
-        <a:font script="Ethi" typeface="Nyala"/>
-        <a:font script="Beng" typeface="Vrinda"/>
-        <a:font script="Gujr" typeface="Shruti"/>
-        <a:font script="Khmr" typeface="DaunPenh"/>
-        <a:font script="Knda" typeface="Tunga"/>
-        <a:font script="Guru" typeface="Raavi"/>
-        <a:font script="Cans" typeface="Euphemia"/>
-        <a:font script="Cher" typeface="Plantagenet Cherokee"/>
-        <a:font script="Yiii" typeface="Microsoft Yi Baiti"/>
-        <a:font script="Tibt" typeface="Microsoft Himalaya"/>
-        <a:font script="Thaa" typeface="MV Boli"/>
-        <a:font script="Deva" typeface="Mangal"/>
-        <a:font script="Telu" typeface="Gautami"/>
-        <a:font script="Taml" typeface="Latha"/>
-        <a:font script="Syrc" typeface="Estrangelo Edessa"/>
-        <a:font script="Orya" typeface="Kalinga"/>
-        <a:font script="Mlym" typeface="Kartika"/>
-        <a:font script="Laoo" typeface="DokChampa"/>
-        <a:font script="Sinh" typeface="Iskoola Pota"/>
-        <a:font script="Mong" typeface="Mongolian Baiti"/>
-        <a:font script="Viet" typeface="Arial"/>
-        <a:font script="Uigh" typeface="Microsoft Uighur"/>
-        <a:font script="Geor" typeface="Sylfaen"/>
-        <a:font script="Armn" typeface="Arial"/>
-        <a:font script="Bugi" typeface="Leelawadee UI"/>
-        <a:font script="Bopo" typeface="Microsoft JhengHei"/>
-        <a:font script="Java" typeface="Javanese Text"/>
-        <a:font script="Lisu" typeface="Segoe UI"/>
-        <a:font script="Mymr" typeface="Myanmar Text"/>
-        <a:font script="Nkoo" typeface="Ebrima"/>
-        <a:font script="Olck" typeface="Nirmala UI"/>
-        <a:font script="Osma" typeface="Ebrima"/>
-        <a:font script="Phag" typeface="Phagspa"/>
-        <a:font script="Syrn" typeface="Estrangelo Edessa"/>
-        <a:font script="Syrj" typeface="Estrangelo Edessa"/>
-        <a:font script="Syre" typeface="Estrangelo Edessa"/>
-        <a:font script="Sora" typeface="Nirmala UI"/>
-        <a:font script="Tale" typeface="Microsoft Tai Le"/>
-        <a:font script="Talu" typeface="Microsoft New Tai Lue"/>
-        <a:font script="Tfng" typeface="Ebrima"/>
-      </a:minorFont>
-    </a:fontScheme>
-    <a:fmtScheme name="Office">
-      <a:fillStyleLst>
-        <a:solidFill>
-          <a:schemeClr val="phClr"/>
-        </a:solidFill>
-        <a:gradFill rotWithShape="1">
-          <a:gsLst>
-            <a:gs pos="0">
-              <a:schemeClr val="phClr">
-                <a:lumMod val="110000"/>
-                <a:satMod val="105000"/>
-                <a:tint val="67000"/>
-              </a:schemeClr>
-            </a:gs>
-            <a:gs pos="50000">
-              <a:schemeClr val="phClr">
-                <a:lumMod val="105000"/>
-                <a:satMod val="103000"/>
-                <a:tint val="73000"/>
-              </a:schemeClr>
-            </a:gs>
-            <a:gs pos="100000">
-              <a:schemeClr val="phClr">
-                <a:lumMod val="105000"/>
-                <a:satMod val="109000"/>
-                <a:tint val="81000"/>
-              </a:schemeClr>
-            </a:gs>
-          </a:gsLst>
-          <a:lin ang="5400000" scaled="0"/>
-        </a:gradFill>
-        <a:gradFill rotWithShape="1">
-          <a:gsLst>
-            <a:gs pos="0">
-              <a:schemeClr val="phClr">
-                <a:satMod val="103000"/>
-                <a:lumMod val="102000"/>
-                <a:tint val="94000"/>
-              </a:schemeClr>
-            </a:gs>
-            <a:gs pos="50000">
-              <a:schemeClr val="phClr">
-                <a:satMod val="110000"/>
-                <a:lumMod val="100000"/>
-                <a:shade val="100000"/>
-              </a:schemeClr>
-            </a:gs>
-            <a:gs pos="100000">
-              <a:schemeClr val="phClr">
-                <a:lumMod val="99000"/>
-                <a:satMod val="120000"/>
-                <a:shade val="78000"/>
-              </a:schemeClr>
-            </a:gs>
-          </a:gsLst>
-          <a:lin ang="5400000" scaled="0"/>
-        </a:gradFill>
-      </a:fillStyleLst>
-      <a:lnStyleLst>
-        <a:ln w="12700" cap="flat" cmpd="sng" algn="ctr">
-          <a:solidFill>
-            <a:schemeClr val="phClr"/>
-          </a:solidFill>
-          <a:prstDash val="solid"/>
-          <a:miter lim="800000"/>
-        </a:ln>
-        <a:ln w="19050" cap="flat" cmpd="sng" algn="ctr">
-          <a:solidFill>
-            <a:schemeClr val="phClr"/>
-          </a:solidFill>
-          <a:prstDash val="solid"/>
-          <a:miter lim="800000"/>
-        </a:ln>
-        <a:ln w="25400" cap="flat" cmpd="sng" algn="ctr">
-          <a:solidFill>
-            <a:schemeClr val="phClr"/>
-          </a:solidFill>
-          <a:prstDash val="solid"/>
-          <a:miter lim="800000"/>
-        </a:ln>
-      </a:lnStyleLst>
-      <a:effectStyleLst>
-        <a:effectStyle>
-          <a:effectLst/>
-        </a:effectStyle>
-        <a:effectStyle>
-          <a:effectLst/>
-        </a:effectStyle>
-        <a:effectStyle>
-          <a:effectLst>
-            <a:outerShdw blurRad="57150" dist="19050" dir="5400000" algn="ctr" rotWithShape="0">
-              <a:srgbClr val="000000">
-                <a:alpha val="63000"/>
-              </a:srgbClr>
-            </a:outerShdw>
-          </a:effectLst>
-        </a:effectStyle>
-      </a:effectStyleLst>
-      <a:bgFillStyleLst>
-        <a:solidFill>
-          <a:schemeClr val="phClr"/>
-        </a:solidFill>
-        <a:solidFill>
-          <a:schemeClr val="phClr">
-            <a:tint val="95000"/>
-            <a:satMod val="170000"/>
-          </a:schemeClr>
-        </a:solidFill>
-        <a:gradFill rotWithShape="1">
-          <a:gsLst>
-            <a:gs pos="0">
-              <a:schemeClr val="phClr">
-                <a:tint val="93000"/>
-                <a:satMod val="150000"/>
-                <a:shade val="98000"/>
-                <a:lumMod val="102000"/>
-              </a:schemeClr>
-            </a:gs>
-            <a:gs pos="50000">
-              <a:schemeClr val="phClr">
-                <a:tint val="98000"/>
-                <a:satMod val="130000"/>
-                <a:shade val="90000"/>
-                <a:lumMod val="103000"/>
-              </a:schemeClr>
-            </a:gs>
-            <a:gs pos="100000">
-              <a:schemeClr val="phClr">
-                <a:shade val="63000"/>
-                <a:satMod val="120000"/>
-              </a:schemeClr>
-            </a:gs>
-          </a:gsLst>
-          <a:lin ang="5400000" scaled="0"/>
-        </a:gradFill>
-      </a:bgFillStyleLst>
-    </a:fmtScheme>
-  </a:themeElements>
-  <a:objectDefaults>
-    <a:lnDef>
-      <a:spPr/>
-      <a:bodyPr/>
-      <a:lstStyle/>
-      <a:style>
-        <a:lnRef idx="2">
-          <a:schemeClr val="accent1"/>
-        </a:lnRef>
-        <a:fillRef idx="0">
-          <a:schemeClr val="accent1"/>
-        </a:fillRef>
-        <a:effectRef idx="1">
-          <a:schemeClr val="accent1"/>
-        </a:effectRef>
-        <a:fontRef idx="minor">
-          <a:schemeClr val="tx1"/>
-        </a:fontRef>
-      </a:style>
-    </a:lnDef>
-  </a:objectDefaults>
-  <a:extraClrSchemeLst/>
-  <a:extLst>
-    <a:ext uri="{05A4C25C-085E-4340-85A3-A5531E510DB2}">
-      <thm15:themeFamily xmlns:thm15="http://schemas.microsoft.com/office/thememl/2012/main" name="Office Theme" id="{2E142A2C-CD16-42D6-873A-C26D2A0506FA}" vid="{1BDDFF52-6CD6-40A5-AB3C-68EB2F1E4D0A}"/>
-    </a:ext>
-  </a:extLst>
-</a:theme>
 </file>
</xml_diff>